<commit_message>
Align report and deck with course concepts
</commit_message>
<xml_diff>
--- a/docs/OpenAlex_DBMS_Comparison_Sapienza.pptx
+++ b/docs/OpenAlex_DBMS_Comparison_Sapienza.pptx
@@ -23,6 +23,9 @@
     <p:sldId id="271" r:id="rId22"/>
     <p:sldId id="272" r:id="rId23"/>
     <p:sldId id="273" r:id="rId24"/>
+    <p:sldId id="274" r:id="rId25"/>
+    <p:sldId id="275" r:id="rId26"/>
+    <p:sldId id="276" r:id="rId27"/>
   </p:sldIdLst>
   <p:sldSz cx="12191695" cy="6858000" type="screen4x3"/>
   <p:notesSz cx="6858000" cy="9144000"/>
@@ -8241,13 +8244,13 @@
           <a:p>
             <a:pPr algn="l"/>
             <a:r>
-              <a:rPr sz="2300" b="1">
-                <a:solidFill>
-                  <a:srgbClr val="1A202C"/>
-                </a:solidFill>
-                <a:latin typeface="Arial"/>
-              </a:rPr>
-              <a:t>PostgreSQL is the better fit for structured tabular analysis and most aggregations in our benchmark. Neo4j is more natural for graph-style questions such as citation paths and author relationship networks.</a:t>
+              <a:rPr sz="2100" b="1">
+                <a:solidFill>
+                  <a:srgbClr val="1F2430"/>
+                </a:solidFill>
+                <a:latin typeface="Aptos"/>
+              </a:rPr>
+              <a:t>PostgreSQL is the better fit for structured tabular analysis and most aggregations. Neo4j is more natural for citation paths and author networks.</a:t>
             </a:r>
           </a:p>
         </p:txBody>
@@ -8276,11 +8279,11 @@
           <a:p>
             <a:pPr algn="l"/>
             <a:r>
-              <a:rPr sz="1600" b="0">
-                <a:solidFill>
-                  <a:srgbClr val="5C6876"/>
-                </a:solidFill>
-                <a:latin typeface="Arial"/>
+              <a:rPr sz="1500" b="0">
+                <a:solidFill>
+                  <a:srgbClr val="566373"/>
+                </a:solidFill>
+                <a:latin typeface="Aptos"/>
               </a:rPr>
               <a:t>The choice depends on the data access pattern, not on one database being universally better.</a:t>
             </a:r>
@@ -8396,6 +8399,679 @@
                 <a:latin typeface="Arial"/>
               </a:rPr>
               <a:t>18</a:t>
+            </a:r>
+          </a:p>
+        </p:txBody>
+      </p:sp>
+    </p:spTree>
+  </p:cSld>
+  <p:clrMapOvr>
+    <a:masterClrMapping/>
+  </p:clrMapOvr>
+</p:sld>
+</file>
+
+<file path=ppt/slides/slide19.xml><?xml version="1.0" encoding="utf-8"?>
+<p:sld xmlns:a="http://schemas.openxmlformats.org/drawingml/2006/main" xmlns:p="http://schemas.openxmlformats.org/presentationml/2006/main" xmlns:r="http://schemas.openxmlformats.org/officeDocument/2006/relationships">
+  <p:cSld>
+    <p:spTree>
+      <p:nvGrpSpPr>
+        <p:cNvPr id="1" name=""/>
+        <p:cNvGrpSpPr/>
+        <p:nvPr/>
+      </p:nvGrpSpPr>
+      <p:grpSpPr/>
+      <p:sp>
+        <p:nvSpPr>
+          <p:cNvPr id="2" name="Rectangle 1"/>
+          <p:cNvSpPr/>
+          <p:nvPr/>
+        </p:nvSpPr>
+        <p:spPr>
+          <a:xfrm>
+            <a:off x="0" y="0"/>
+            <a:ext cx="12191695" cy="457200"/>
+          </a:xfrm>
+          <a:prstGeom prst="rect">
+            <a:avLst/>
+          </a:prstGeom>
+          <a:solidFill>
+            <a:srgbClr val="822332"/>
+          </a:solidFill>
+          <a:ln>
+            <a:noFill/>
+          </a:ln>
+        </p:spPr>
+        <p:style>
+          <a:lnRef idx="1">
+            <a:schemeClr val="accent1"/>
+          </a:lnRef>
+          <a:fillRef idx="3">
+            <a:schemeClr val="accent1"/>
+          </a:fillRef>
+          <a:effectRef idx="2">
+            <a:schemeClr val="accent1"/>
+          </a:effectRef>
+          <a:fontRef idx="minor">
+            <a:schemeClr val="lt1"/>
+          </a:fontRef>
+        </p:style>
+        <p:txBody>
+          <a:bodyPr rtlCol="0" anchor="ctr"/>
+          <a:lstStyle/>
+          <a:p>
+            <a:pPr algn="ctr"/>
+          </a:p>
+        </p:txBody>
+      </p:sp>
+      <p:sp>
+        <p:nvSpPr>
+          <p:cNvPr id="3" name="TextBox 2"/>
+          <p:cNvSpPr txBox="1"/>
+          <p:nvPr/>
+        </p:nvSpPr>
+        <p:spPr>
+          <a:xfrm>
+            <a:off x="502920" y="594360"/>
+            <a:ext cx="8961120" cy="411480"/>
+          </a:xfrm>
+          <a:prstGeom prst="rect">
+            <a:avLst/>
+          </a:prstGeom>
+          <a:noFill/>
+        </p:spPr>
+        <p:txBody>
+          <a:bodyPr wrap="square" lIns="54864" rIns="54864" tIns="27432" bIns="27432">
+            <a:spAutoFit/>
+          </a:bodyPr>
+          <a:lstStyle/>
+          <a:p>
+            <a:pPr algn="l"/>
+            <a:r>
+              <a:rPr sz="2700" b="1">
+                <a:solidFill>
+                  <a:srgbClr val="52121E"/>
+                </a:solidFill>
+                <a:latin typeface="Arial"/>
+              </a:rPr>
+              <a:t>Course Connection: Graph Databases</a:t>
+            </a:r>
+          </a:p>
+        </p:txBody>
+      </p:sp>
+      <p:sp>
+        <p:nvSpPr>
+          <p:cNvPr id="4" name="TextBox 3"/>
+          <p:cNvSpPr txBox="1"/>
+          <p:nvPr/>
+        </p:nvSpPr>
+        <p:spPr>
+          <a:xfrm>
+            <a:off x="530352" y="987552"/>
+            <a:ext cx="8686800" cy="256032"/>
+          </a:xfrm>
+          <a:prstGeom prst="rect">
+            <a:avLst/>
+          </a:prstGeom>
+          <a:noFill/>
+        </p:spPr>
+        <p:txBody>
+          <a:bodyPr wrap="square" lIns="54864" rIns="54864" tIns="27432" bIns="27432">
+            <a:spAutoFit/>
+          </a:bodyPr>
+          <a:lstStyle/>
+          <a:p>
+            <a:pPr algn="l"/>
+            <a:r>
+              <a:rPr sz="1200" b="0">
+                <a:solidFill>
+                  <a:srgbClr val="5C6876"/>
+                </a:solidFill>
+                <a:latin typeface="Arial"/>
+              </a:rPr>
+              <a:t>How the lecture concepts appear in our implementation</a:t>
+            </a:r>
+          </a:p>
+        </p:txBody>
+      </p:sp>
+      <p:pic>
+        <p:nvPicPr>
+          <p:cNvPr id="5" name="Picture 4" descr="image.png"/>
+          <p:cNvPicPr>
+            <a:picLocks noChangeAspect="1"/>
+          </p:cNvPicPr>
+          <p:nvPr/>
+        </p:nvPicPr>
+        <p:blipFill>
+          <a:blip r:embed="rId2"/>
+          <a:stretch>
+            <a:fillRect/>
+          </a:stretch>
+        </p:blipFill>
+        <p:spPr>
+          <a:xfrm>
+            <a:off x="11018520" y="566928"/>
+            <a:ext cx="566928" cy="679252"/>
+          </a:xfrm>
+          <a:prstGeom prst="rect">
+            <a:avLst/>
+          </a:prstGeom>
+        </p:spPr>
+      </p:pic>
+      <p:sp>
+        <p:nvSpPr>
+          <p:cNvPr id="6" name="TextBox 5"/>
+          <p:cNvSpPr txBox="1"/>
+          <p:nvPr/>
+        </p:nvSpPr>
+        <p:spPr>
+          <a:xfrm>
+            <a:off x="502920" y="6446520"/>
+            <a:ext cx="4206240" cy="201168"/>
+          </a:xfrm>
+          <a:prstGeom prst="rect">
+            <a:avLst/>
+          </a:prstGeom>
+          <a:noFill/>
+        </p:spPr>
+        <p:txBody>
+          <a:bodyPr wrap="square" lIns="54864" rIns="54864" tIns="27432" bIns="27432">
+            <a:spAutoFit/>
+          </a:bodyPr>
+          <a:lstStyle/>
+          <a:p>
+            <a:pPr algn="l"/>
+            <a:r>
+              <a:rPr sz="800" b="0">
+                <a:solidFill>
+                  <a:srgbClr val="5C6876"/>
+                </a:solidFill>
+                <a:latin typeface="Arial"/>
+              </a:rPr>
+              <a:t>OpenAlex AI DBMS Comparison</a:t>
+            </a:r>
+          </a:p>
+        </p:txBody>
+      </p:sp>
+      <p:sp>
+        <p:nvSpPr>
+          <p:cNvPr id="7" name="TextBox 6"/>
+          <p:cNvSpPr txBox="1"/>
+          <p:nvPr/>
+        </p:nvSpPr>
+        <p:spPr>
+          <a:xfrm>
+            <a:off x="11292840" y="6446520"/>
+            <a:ext cx="411480" cy="201168"/>
+          </a:xfrm>
+          <a:prstGeom prst="rect">
+            <a:avLst/>
+          </a:prstGeom>
+          <a:noFill/>
+        </p:spPr>
+        <p:txBody>
+          <a:bodyPr wrap="square" lIns="54864" rIns="54864" tIns="27432" bIns="27432">
+            <a:spAutoFit/>
+          </a:bodyPr>
+          <a:lstStyle/>
+          <a:p>
+            <a:pPr algn="r"/>
+            <a:r>
+              <a:rPr sz="800" b="0">
+                <a:solidFill>
+                  <a:srgbClr val="5C6876"/>
+                </a:solidFill>
+                <a:latin typeface="Arial"/>
+              </a:rPr>
+              <a:t>19</a:t>
+            </a:r>
+          </a:p>
+        </p:txBody>
+      </p:sp>
+      <p:sp>
+        <p:nvSpPr>
+          <p:cNvPr id="8" name="Rounded Rectangle 7"/>
+          <p:cNvSpPr/>
+          <p:nvPr/>
+        </p:nvSpPr>
+        <p:spPr>
+          <a:xfrm>
+            <a:off x="685800" y="1417320"/>
+            <a:ext cx="3291840" cy="4343400"/>
+          </a:xfrm>
+          <a:prstGeom prst="roundRect">
+            <a:avLst/>
+          </a:prstGeom>
+          <a:solidFill>
+            <a:srgbClr val="FBFBFB"/>
+          </a:solidFill>
+          <a:ln w="15240">
+            <a:solidFill>
+              <a:srgbClr val="DCDCDC"/>
+            </a:solidFill>
+          </a:ln>
+        </p:spPr>
+        <p:style>
+          <a:lnRef idx="1">
+            <a:schemeClr val="accent1"/>
+          </a:lnRef>
+          <a:fillRef idx="3">
+            <a:schemeClr val="accent1"/>
+          </a:fillRef>
+          <a:effectRef idx="2">
+            <a:schemeClr val="accent1"/>
+          </a:effectRef>
+          <a:fontRef idx="minor">
+            <a:schemeClr val="lt1"/>
+          </a:fontRef>
+        </p:style>
+        <p:txBody>
+          <a:bodyPr rtlCol="0" anchor="ctr"/>
+          <a:lstStyle/>
+          <a:p>
+            <a:pPr algn="ctr"/>
+          </a:p>
+        </p:txBody>
+      </p:sp>
+      <p:sp>
+        <p:nvSpPr>
+          <p:cNvPr id="9" name="TextBox 8"/>
+          <p:cNvSpPr txBox="1"/>
+          <p:nvPr/>
+        </p:nvSpPr>
+        <p:spPr>
+          <a:xfrm>
+            <a:off x="960120" y="1664208"/>
+            <a:ext cx="2103120" cy="274320"/>
+          </a:xfrm>
+          <a:prstGeom prst="rect">
+            <a:avLst/>
+          </a:prstGeom>
+          <a:noFill/>
+        </p:spPr>
+        <p:txBody>
+          <a:bodyPr wrap="square" lIns="54864" rIns="54864" tIns="27432" bIns="27432">
+            <a:spAutoFit/>
+          </a:bodyPr>
+          <a:lstStyle/>
+          <a:p>
+            <a:pPr algn="l"/>
+            <a:r>
+              <a:rPr sz="1700" b="1">
+                <a:solidFill>
+                  <a:srgbClr val="52121E"/>
+                </a:solidFill>
+                <a:latin typeface="Arial"/>
+              </a:rPr>
+              <a:t>Lecture idea</a:t>
+            </a:r>
+          </a:p>
+        </p:txBody>
+      </p:sp>
+      <p:sp>
+        <p:nvSpPr>
+          <p:cNvPr id="10" name="TextBox 9"/>
+          <p:cNvSpPr txBox="1"/>
+          <p:nvPr/>
+        </p:nvSpPr>
+        <p:spPr>
+          <a:xfrm>
+            <a:off x="960120" y="2084831"/>
+            <a:ext cx="2606040" cy="2560320"/>
+          </a:xfrm>
+          <a:prstGeom prst="rect">
+            <a:avLst/>
+          </a:prstGeom>
+          <a:noFill/>
+        </p:spPr>
+        <p:txBody>
+          <a:bodyPr wrap="square" lIns="54864" rIns="54864" tIns="27432" bIns="27432">
+            <a:spAutoFit/>
+          </a:bodyPr>
+          <a:lstStyle/>
+          <a:p>
+            <a:pPr algn="l">
+              <a:spcAft>
+                <a:spcPts val="500"/>
+              </a:spcAft>
+            </a:pPr>
+            <a:r>
+              <a:rPr sz="1600" b="0">
+                <a:solidFill>
+                  <a:srgbClr val="1A202C"/>
+                </a:solidFill>
+                <a:latin typeface="Arial"/>
+              </a:rPr>
+              <a:t>- Relationships can be represented as explicit graph edges</a:t>
+            </a:r>
+            <a:br/>
+            <a:r>
+              <a:rPr sz="1600" b="0">
+                <a:solidFill>
+                  <a:srgbClr val="1A202C"/>
+                </a:solidFill>
+                <a:latin typeface="Arial"/>
+              </a:rPr>
+              <a:t>- Graph data is useful when paths and networks matter</a:t>
+            </a:r>
+            <a:br/>
+            <a:r>
+              <a:rPr sz="1600" b="0">
+                <a:solidFill>
+                  <a:srgbClr val="1A202C"/>
+                </a:solidFill>
+                <a:latin typeface="Arial"/>
+              </a:rPr>
+              <a:t>- Traversal follows connected nodes and relationships</a:t>
+            </a:r>
+          </a:p>
+        </p:txBody>
+      </p:sp>
+      <p:sp>
+        <p:nvSpPr>
+          <p:cNvPr id="11" name="Rounded Rectangle 10"/>
+          <p:cNvSpPr/>
+          <p:nvPr/>
+        </p:nvSpPr>
+        <p:spPr>
+          <a:xfrm>
+            <a:off x="4434840" y="1417320"/>
+            <a:ext cx="3291840" cy="4343400"/>
+          </a:xfrm>
+          <a:prstGeom prst="roundRect">
+            <a:avLst/>
+          </a:prstGeom>
+          <a:solidFill>
+            <a:srgbClr val="FBFBFB"/>
+          </a:solidFill>
+          <a:ln w="15240">
+            <a:solidFill>
+              <a:srgbClr val="DCDCDC"/>
+            </a:solidFill>
+          </a:ln>
+        </p:spPr>
+        <p:style>
+          <a:lnRef idx="1">
+            <a:schemeClr val="accent1"/>
+          </a:lnRef>
+          <a:fillRef idx="3">
+            <a:schemeClr val="accent1"/>
+          </a:fillRef>
+          <a:effectRef idx="2">
+            <a:schemeClr val="accent1"/>
+          </a:effectRef>
+          <a:fontRef idx="minor">
+            <a:schemeClr val="lt1"/>
+          </a:fontRef>
+        </p:style>
+        <p:txBody>
+          <a:bodyPr rtlCol="0" anchor="ctr"/>
+          <a:lstStyle/>
+          <a:p>
+            <a:pPr algn="ctr"/>
+          </a:p>
+        </p:txBody>
+      </p:sp>
+      <p:sp>
+        <p:nvSpPr>
+          <p:cNvPr id="12" name="TextBox 11"/>
+          <p:cNvSpPr txBox="1"/>
+          <p:nvPr/>
+        </p:nvSpPr>
+        <p:spPr>
+          <a:xfrm>
+            <a:off x="4709160" y="1664208"/>
+            <a:ext cx="2286000" cy="274320"/>
+          </a:xfrm>
+          <a:prstGeom prst="rect">
+            <a:avLst/>
+          </a:prstGeom>
+          <a:noFill/>
+        </p:spPr>
+        <p:txBody>
+          <a:bodyPr wrap="square" lIns="54864" rIns="54864" tIns="27432" bIns="27432">
+            <a:spAutoFit/>
+          </a:bodyPr>
+          <a:lstStyle/>
+          <a:p>
+            <a:pPr algn="l"/>
+            <a:r>
+              <a:rPr sz="1700" b="1">
+                <a:solidFill>
+                  <a:srgbClr val="52121E"/>
+                </a:solidFill>
+                <a:latin typeface="Arial"/>
+              </a:rPr>
+              <a:t>Our Neo4j model</a:t>
+            </a:r>
+          </a:p>
+        </p:txBody>
+      </p:sp>
+      <p:sp>
+        <p:nvSpPr>
+          <p:cNvPr id="13" name="TextBox 12"/>
+          <p:cNvSpPr txBox="1"/>
+          <p:nvPr/>
+        </p:nvSpPr>
+        <p:spPr>
+          <a:xfrm>
+            <a:off x="4709160" y="2084831"/>
+            <a:ext cx="2606040" cy="2560320"/>
+          </a:xfrm>
+          <a:prstGeom prst="rect">
+            <a:avLst/>
+          </a:prstGeom>
+          <a:noFill/>
+        </p:spPr>
+        <p:txBody>
+          <a:bodyPr wrap="square" lIns="54864" rIns="54864" tIns="27432" bIns="27432">
+            <a:spAutoFit/>
+          </a:bodyPr>
+          <a:lstStyle/>
+          <a:p>
+            <a:pPr algn="l">
+              <a:spcAft>
+                <a:spcPts val="500"/>
+              </a:spcAft>
+            </a:pPr>
+            <a:r>
+              <a:rPr sz="1600" b="0">
+                <a:solidFill>
+                  <a:srgbClr val="1A202C"/>
+                </a:solidFill>
+                <a:latin typeface="Arial"/>
+              </a:rPr>
+              <a:t>- Nodes: Paper, Author, Topic</a:t>
+            </a:r>
+            <a:br/>
+            <a:r>
+              <a:rPr sz="1600" b="0">
+                <a:solidFill>
+                  <a:srgbClr val="1A202C"/>
+                </a:solidFill>
+                <a:latin typeface="Arial"/>
+              </a:rPr>
+              <a:t>- Edges: AUTHORED, HAS_TOPIC, CITES</a:t>
+            </a:r>
+            <a:br/>
+            <a:r>
+              <a:rPr sz="1600" b="0">
+                <a:solidFill>
+                  <a:srgbClr val="1A202C"/>
+                </a:solidFill>
+                <a:latin typeface="Arial"/>
+              </a:rPr>
+              <a:t>- Citation and authorship paths are visible in Neo4j Browser</a:t>
+            </a:r>
+          </a:p>
+        </p:txBody>
+      </p:sp>
+      <p:sp>
+        <p:nvSpPr>
+          <p:cNvPr id="14" name="Rounded Rectangle 13"/>
+          <p:cNvSpPr/>
+          <p:nvPr/>
+        </p:nvSpPr>
+        <p:spPr>
+          <a:xfrm>
+            <a:off x="8183879" y="1417320"/>
+            <a:ext cx="3291840" cy="4343400"/>
+          </a:xfrm>
+          <a:prstGeom prst="roundRect">
+            <a:avLst/>
+          </a:prstGeom>
+          <a:solidFill>
+            <a:srgbClr val="FBFBFB"/>
+          </a:solidFill>
+          <a:ln w="15240">
+            <a:solidFill>
+              <a:srgbClr val="DCDCDC"/>
+            </a:solidFill>
+          </a:ln>
+        </p:spPr>
+        <p:style>
+          <a:lnRef idx="1">
+            <a:schemeClr val="accent1"/>
+          </a:lnRef>
+          <a:fillRef idx="3">
+            <a:schemeClr val="accent1"/>
+          </a:fillRef>
+          <a:effectRef idx="2">
+            <a:schemeClr val="accent1"/>
+          </a:effectRef>
+          <a:fontRef idx="minor">
+            <a:schemeClr val="lt1"/>
+          </a:fontRef>
+        </p:style>
+        <p:txBody>
+          <a:bodyPr rtlCol="0" anchor="ctr"/>
+          <a:lstStyle/>
+          <a:p>
+            <a:pPr algn="ctr"/>
+          </a:p>
+        </p:txBody>
+      </p:sp>
+      <p:sp>
+        <p:nvSpPr>
+          <p:cNvPr id="15" name="TextBox 14"/>
+          <p:cNvSpPr txBox="1"/>
+          <p:nvPr/>
+        </p:nvSpPr>
+        <p:spPr>
+          <a:xfrm>
+            <a:off x="8458200" y="1664208"/>
+            <a:ext cx="2286000" cy="274320"/>
+          </a:xfrm>
+          <a:prstGeom prst="rect">
+            <a:avLst/>
+          </a:prstGeom>
+          <a:noFill/>
+        </p:spPr>
+        <p:txBody>
+          <a:bodyPr wrap="square" lIns="54864" rIns="54864" tIns="27432" bIns="27432">
+            <a:spAutoFit/>
+          </a:bodyPr>
+          <a:lstStyle/>
+          <a:p>
+            <a:pPr algn="l"/>
+            <a:r>
+              <a:rPr sz="1700" b="1">
+                <a:solidFill>
+                  <a:srgbClr val="52121E"/>
+                </a:solidFill>
+                <a:latin typeface="Arial"/>
+              </a:rPr>
+              <a:t>Project example</a:t>
+            </a:r>
+          </a:p>
+        </p:txBody>
+      </p:sp>
+      <p:sp>
+        <p:nvSpPr>
+          <p:cNvPr id="16" name="TextBox 15"/>
+          <p:cNvSpPr txBox="1"/>
+          <p:nvPr/>
+        </p:nvSpPr>
+        <p:spPr>
+          <a:xfrm>
+            <a:off x="8458200" y="2194560"/>
+            <a:ext cx="2606040" cy="1234440"/>
+          </a:xfrm>
+          <a:prstGeom prst="rect">
+            <a:avLst/>
+          </a:prstGeom>
+          <a:noFill/>
+        </p:spPr>
+        <p:txBody>
+          <a:bodyPr wrap="square" lIns="54864" rIns="54864" tIns="27432" bIns="27432">
+            <a:spAutoFit/>
+          </a:bodyPr>
+          <a:lstStyle/>
+          <a:p>
+            <a:pPr algn="l"/>
+            <a:r>
+              <a:rPr sz="1500" b="1">
+                <a:solidFill>
+                  <a:srgbClr val="1A202C"/>
+                </a:solidFill>
+                <a:latin typeface="Arial"/>
+              </a:rPr>
+              <a:t>(Author)-[:AUTHORED]-&gt;(Paper)</a:t>
+            </a:r>
+            <a:br/>
+            <a:r>
+              <a:rPr sz="1500" b="1">
+                <a:solidFill>
+                  <a:srgbClr val="1A202C"/>
+                </a:solidFill>
+                <a:latin typeface="Arial"/>
+              </a:rPr>
+              <a:t>(Paper)-[:CITES]-&gt;(Paper)</a:t>
+            </a:r>
+            <a:br/>
+            <a:r>
+              <a:rPr sz="1500" b="1">
+                <a:solidFill>
+                  <a:srgbClr val="1A202C"/>
+                </a:solidFill>
+                <a:latin typeface="Arial"/>
+              </a:rPr>
+              <a:t>(Paper)-[:HAS_TOPIC]-&gt;(Topic)</a:t>
+            </a:r>
+          </a:p>
+        </p:txBody>
+      </p:sp>
+      <p:sp>
+        <p:nvSpPr>
+          <p:cNvPr id="17" name="TextBox 16"/>
+          <p:cNvSpPr txBox="1"/>
+          <p:nvPr/>
+        </p:nvSpPr>
+        <p:spPr>
+          <a:xfrm>
+            <a:off x="8458200" y="4069080"/>
+            <a:ext cx="2606040" cy="640080"/>
+          </a:xfrm>
+          <a:prstGeom prst="rect">
+            <a:avLst/>
+          </a:prstGeom>
+          <a:noFill/>
+        </p:spPr>
+        <p:txBody>
+          <a:bodyPr wrap="square" lIns="54864" rIns="54864" tIns="27432" bIns="27432">
+            <a:spAutoFit/>
+          </a:bodyPr>
+          <a:lstStyle/>
+          <a:p>
+            <a:pPr algn="l"/>
+            <a:r>
+              <a:rPr sz="1600" b="0">
+                <a:solidFill>
+                  <a:srgbClr val="1A202C"/>
+                </a:solidFill>
+                <a:latin typeface="Arial"/>
+              </a:rPr>
+              <a:t>This directly applies the property graph model explained in class.</a:t>
             </a:r>
           </a:p>
         </p:txBody>
@@ -8925,6 +9601,1231 @@
                 <a:latin typeface="Arial"/>
               </a:rPr>
               <a:t>2</a:t>
+            </a:r>
+          </a:p>
+        </p:txBody>
+      </p:sp>
+    </p:spTree>
+  </p:cSld>
+  <p:clrMapOvr>
+    <a:masterClrMapping/>
+  </p:clrMapOvr>
+</p:sld>
+</file>
+
+<file path=ppt/slides/slide20.xml><?xml version="1.0" encoding="utf-8"?>
+<p:sld xmlns:a="http://schemas.openxmlformats.org/drawingml/2006/main" xmlns:p="http://schemas.openxmlformats.org/presentationml/2006/main" xmlns:r="http://schemas.openxmlformats.org/officeDocument/2006/relationships">
+  <p:cSld>
+    <p:spTree>
+      <p:nvGrpSpPr>
+        <p:cNvPr id="1" name=""/>
+        <p:cNvGrpSpPr/>
+        <p:nvPr/>
+      </p:nvGrpSpPr>
+      <p:grpSpPr/>
+      <p:sp>
+        <p:nvSpPr>
+          <p:cNvPr id="2" name="Rectangle 1"/>
+          <p:cNvSpPr/>
+          <p:nvPr/>
+        </p:nvSpPr>
+        <p:spPr>
+          <a:xfrm>
+            <a:off x="0" y="0"/>
+            <a:ext cx="12191695" cy="457200"/>
+          </a:xfrm>
+          <a:prstGeom prst="rect">
+            <a:avLst/>
+          </a:prstGeom>
+          <a:solidFill>
+            <a:srgbClr val="822332"/>
+          </a:solidFill>
+          <a:ln>
+            <a:noFill/>
+          </a:ln>
+        </p:spPr>
+        <p:style>
+          <a:lnRef idx="1">
+            <a:schemeClr val="accent1"/>
+          </a:lnRef>
+          <a:fillRef idx="3">
+            <a:schemeClr val="accent1"/>
+          </a:fillRef>
+          <a:effectRef idx="2">
+            <a:schemeClr val="accent1"/>
+          </a:effectRef>
+          <a:fontRef idx="minor">
+            <a:schemeClr val="lt1"/>
+          </a:fontRef>
+        </p:style>
+        <p:txBody>
+          <a:bodyPr rtlCol="0" anchor="ctr"/>
+          <a:lstStyle/>
+          <a:p>
+            <a:pPr algn="ctr"/>
+          </a:p>
+        </p:txBody>
+      </p:sp>
+      <p:sp>
+        <p:nvSpPr>
+          <p:cNvPr id="3" name="TextBox 2"/>
+          <p:cNvSpPr txBox="1"/>
+          <p:nvPr/>
+        </p:nvSpPr>
+        <p:spPr>
+          <a:xfrm>
+            <a:off x="502920" y="594360"/>
+            <a:ext cx="8961120" cy="411480"/>
+          </a:xfrm>
+          <a:prstGeom prst="rect">
+            <a:avLst/>
+          </a:prstGeom>
+          <a:noFill/>
+        </p:spPr>
+        <p:txBody>
+          <a:bodyPr wrap="square" lIns="54864" rIns="54864" tIns="27432" bIns="27432">
+            <a:spAutoFit/>
+          </a:bodyPr>
+          <a:lstStyle/>
+          <a:p>
+            <a:pPr algn="l"/>
+            <a:r>
+              <a:rPr sz="2700" b="1">
+                <a:solidFill>
+                  <a:srgbClr val="52121E"/>
+                </a:solidFill>
+                <a:latin typeface="Arial"/>
+              </a:rPr>
+              <a:t>Course Connection: Joins vs Traversal</a:t>
+            </a:r>
+          </a:p>
+        </p:txBody>
+      </p:sp>
+      <p:sp>
+        <p:nvSpPr>
+          <p:cNvPr id="4" name="TextBox 3"/>
+          <p:cNvSpPr txBox="1"/>
+          <p:nvPr/>
+        </p:nvSpPr>
+        <p:spPr>
+          <a:xfrm>
+            <a:off x="530352" y="987552"/>
+            <a:ext cx="8686800" cy="256032"/>
+          </a:xfrm>
+          <a:prstGeom prst="rect">
+            <a:avLst/>
+          </a:prstGeom>
+          <a:noFill/>
+        </p:spPr>
+        <p:txBody>
+          <a:bodyPr wrap="square" lIns="54864" rIns="54864" tIns="27432" bIns="27432">
+            <a:spAutoFit/>
+          </a:bodyPr>
+          <a:lstStyle/>
+          <a:p>
+            <a:pPr algn="l"/>
+            <a:r>
+              <a:rPr sz="1200" b="0">
+                <a:solidFill>
+                  <a:srgbClr val="5C6876"/>
+                </a:solidFill>
+                <a:latin typeface="Arial"/>
+              </a:rPr>
+              <a:t>Same relationship question, two database perspectives</a:t>
+            </a:r>
+          </a:p>
+        </p:txBody>
+      </p:sp>
+      <p:pic>
+        <p:nvPicPr>
+          <p:cNvPr id="5" name="Picture 4" descr="image.png"/>
+          <p:cNvPicPr>
+            <a:picLocks noChangeAspect="1"/>
+          </p:cNvPicPr>
+          <p:nvPr/>
+        </p:nvPicPr>
+        <p:blipFill>
+          <a:blip r:embed="rId2"/>
+          <a:stretch>
+            <a:fillRect/>
+          </a:stretch>
+        </p:blipFill>
+        <p:spPr>
+          <a:xfrm>
+            <a:off x="11018520" y="566928"/>
+            <a:ext cx="566928" cy="679252"/>
+          </a:xfrm>
+          <a:prstGeom prst="rect">
+            <a:avLst/>
+          </a:prstGeom>
+        </p:spPr>
+      </p:pic>
+      <p:sp>
+        <p:nvSpPr>
+          <p:cNvPr id="6" name="TextBox 5"/>
+          <p:cNvSpPr txBox="1"/>
+          <p:nvPr/>
+        </p:nvSpPr>
+        <p:spPr>
+          <a:xfrm>
+            <a:off x="502920" y="6446520"/>
+            <a:ext cx="4206240" cy="201168"/>
+          </a:xfrm>
+          <a:prstGeom prst="rect">
+            <a:avLst/>
+          </a:prstGeom>
+          <a:noFill/>
+        </p:spPr>
+        <p:txBody>
+          <a:bodyPr wrap="square" lIns="54864" rIns="54864" tIns="27432" bIns="27432">
+            <a:spAutoFit/>
+          </a:bodyPr>
+          <a:lstStyle/>
+          <a:p>
+            <a:pPr algn="l"/>
+            <a:r>
+              <a:rPr sz="800" b="0">
+                <a:solidFill>
+                  <a:srgbClr val="5C6876"/>
+                </a:solidFill>
+                <a:latin typeface="Arial"/>
+              </a:rPr>
+              <a:t>OpenAlex AI DBMS Comparison</a:t>
+            </a:r>
+          </a:p>
+        </p:txBody>
+      </p:sp>
+      <p:sp>
+        <p:nvSpPr>
+          <p:cNvPr id="7" name="TextBox 6"/>
+          <p:cNvSpPr txBox="1"/>
+          <p:nvPr/>
+        </p:nvSpPr>
+        <p:spPr>
+          <a:xfrm>
+            <a:off x="11292840" y="6446520"/>
+            <a:ext cx="411480" cy="201168"/>
+          </a:xfrm>
+          <a:prstGeom prst="rect">
+            <a:avLst/>
+          </a:prstGeom>
+          <a:noFill/>
+        </p:spPr>
+        <p:txBody>
+          <a:bodyPr wrap="square" lIns="54864" rIns="54864" tIns="27432" bIns="27432">
+            <a:spAutoFit/>
+          </a:bodyPr>
+          <a:lstStyle/>
+          <a:p>
+            <a:pPr algn="r"/>
+            <a:r>
+              <a:rPr sz="800" b="0">
+                <a:solidFill>
+                  <a:srgbClr val="5C6876"/>
+                </a:solidFill>
+                <a:latin typeface="Arial"/>
+              </a:rPr>
+              <a:t>20</a:t>
+            </a:r>
+          </a:p>
+        </p:txBody>
+      </p:sp>
+      <p:sp>
+        <p:nvSpPr>
+          <p:cNvPr id="8" name="Rounded Rectangle 7"/>
+          <p:cNvSpPr/>
+          <p:nvPr/>
+        </p:nvSpPr>
+        <p:spPr>
+          <a:xfrm>
+            <a:off x="685800" y="1417320"/>
+            <a:ext cx="5120640" cy="4434840"/>
+          </a:xfrm>
+          <a:prstGeom prst="roundRect">
+            <a:avLst/>
+          </a:prstGeom>
+          <a:solidFill>
+            <a:srgbClr val="FBFBFB"/>
+          </a:solidFill>
+          <a:ln w="15240">
+            <a:solidFill>
+              <a:srgbClr val="DCDCDC"/>
+            </a:solidFill>
+          </a:ln>
+        </p:spPr>
+        <p:style>
+          <a:lnRef idx="1">
+            <a:schemeClr val="accent1"/>
+          </a:lnRef>
+          <a:fillRef idx="3">
+            <a:schemeClr val="accent1"/>
+          </a:fillRef>
+          <a:effectRef idx="2">
+            <a:schemeClr val="accent1"/>
+          </a:effectRef>
+          <a:fontRef idx="minor">
+            <a:schemeClr val="lt1"/>
+          </a:fontRef>
+        </p:style>
+        <p:txBody>
+          <a:bodyPr rtlCol="0" anchor="ctr"/>
+          <a:lstStyle/>
+          <a:p>
+            <a:pPr algn="ctr"/>
+          </a:p>
+        </p:txBody>
+      </p:sp>
+      <p:sp>
+        <p:nvSpPr>
+          <p:cNvPr id="9" name="TextBox 8"/>
+          <p:cNvSpPr txBox="1"/>
+          <p:nvPr/>
+        </p:nvSpPr>
+        <p:spPr>
+          <a:xfrm>
+            <a:off x="960120" y="1691640"/>
+            <a:ext cx="3840480" cy="274320"/>
+          </a:xfrm>
+          <a:prstGeom prst="rect">
+            <a:avLst/>
+          </a:prstGeom>
+          <a:noFill/>
+        </p:spPr>
+        <p:txBody>
+          <a:bodyPr wrap="square" lIns="54864" rIns="54864" tIns="27432" bIns="27432">
+            <a:spAutoFit/>
+          </a:bodyPr>
+          <a:lstStyle/>
+          <a:p>
+            <a:pPr algn="l"/>
+            <a:r>
+              <a:rPr sz="1800" b="1">
+                <a:solidFill>
+                  <a:srgbClr val="52121E"/>
+                </a:solidFill>
+                <a:latin typeface="Arial"/>
+              </a:rPr>
+              <a:t>PostgreSQL: relationships through joins</a:t>
+            </a:r>
+          </a:p>
+        </p:txBody>
+      </p:sp>
+      <p:sp>
+        <p:nvSpPr>
+          <p:cNvPr id="10" name="TextBox 9"/>
+          <p:cNvSpPr txBox="1"/>
+          <p:nvPr/>
+        </p:nvSpPr>
+        <p:spPr>
+          <a:xfrm>
+            <a:off x="960120" y="2148840"/>
+            <a:ext cx="4343400" cy="2286000"/>
+          </a:xfrm>
+          <a:prstGeom prst="rect">
+            <a:avLst/>
+          </a:prstGeom>
+          <a:noFill/>
+        </p:spPr>
+        <p:txBody>
+          <a:bodyPr wrap="square" lIns="54864" rIns="54864" tIns="27432" bIns="27432">
+            <a:spAutoFit/>
+          </a:bodyPr>
+          <a:lstStyle/>
+          <a:p>
+            <a:pPr algn="l">
+              <a:spcAft>
+                <a:spcPts val="500"/>
+              </a:spcAft>
+            </a:pPr>
+            <a:r>
+              <a:rPr sz="1700" b="0">
+                <a:solidFill>
+                  <a:srgbClr val="1A202C"/>
+                </a:solidFill>
+                <a:latin typeface="Arial"/>
+              </a:rPr>
+              <a:t>- Relationships are stored in tables and bridge tables</a:t>
+            </a:r>
+            <a:br/>
+            <a:r>
+              <a:rPr sz="1700" b="0">
+                <a:solidFill>
+                  <a:srgbClr val="1A202C"/>
+                </a:solidFill>
+                <a:latin typeface="Arial"/>
+              </a:rPr>
+              <a:t>- Author citation network requires joins across paper_authors, citations, and authors</a:t>
+            </a:r>
+            <a:br/>
+            <a:r>
+              <a:rPr sz="1700" b="0">
+                <a:solidFill>
+                  <a:srgbClr val="1A202C"/>
+                </a:solidFill>
+                <a:latin typeface="Arial"/>
+              </a:rPr>
+              <a:t>- Good for structured aggregation, sorting, and filtering</a:t>
+            </a:r>
+          </a:p>
+        </p:txBody>
+      </p:sp>
+      <p:sp>
+        <p:nvSpPr>
+          <p:cNvPr id="11" name="TextBox 10"/>
+          <p:cNvSpPr txBox="1"/>
+          <p:nvPr/>
+        </p:nvSpPr>
+        <p:spPr>
+          <a:xfrm>
+            <a:off x="960120" y="4892040"/>
+            <a:ext cx="4343400" cy="502920"/>
+          </a:xfrm>
+          <a:prstGeom prst="rect">
+            <a:avLst/>
+          </a:prstGeom>
+          <a:noFill/>
+        </p:spPr>
+        <p:txBody>
+          <a:bodyPr wrap="square" lIns="54864" rIns="54864" tIns="27432" bIns="27432">
+            <a:spAutoFit/>
+          </a:bodyPr>
+          <a:lstStyle/>
+          <a:p>
+            <a:pPr algn="l"/>
+            <a:r>
+              <a:rPr sz="1500" b="0">
+                <a:solidFill>
+                  <a:srgbClr val="1A202C"/>
+                </a:solidFill>
+                <a:latin typeface="Arial"/>
+              </a:rPr>
+              <a:t>Course link: relational query processing uses operators such as join, selection, grouping, and ordering.</a:t>
+            </a:r>
+          </a:p>
+        </p:txBody>
+      </p:sp>
+      <p:sp>
+        <p:nvSpPr>
+          <p:cNvPr id="12" name="Rounded Rectangle 11"/>
+          <p:cNvSpPr/>
+          <p:nvPr/>
+        </p:nvSpPr>
+        <p:spPr>
+          <a:xfrm>
+            <a:off x="6355080" y="1417320"/>
+            <a:ext cx="5120640" cy="4434840"/>
+          </a:xfrm>
+          <a:prstGeom prst="roundRect">
+            <a:avLst/>
+          </a:prstGeom>
+          <a:solidFill>
+            <a:srgbClr val="FBFBFB"/>
+          </a:solidFill>
+          <a:ln w="15240">
+            <a:solidFill>
+              <a:srgbClr val="DCDCDC"/>
+            </a:solidFill>
+          </a:ln>
+        </p:spPr>
+        <p:style>
+          <a:lnRef idx="1">
+            <a:schemeClr val="accent1"/>
+          </a:lnRef>
+          <a:fillRef idx="3">
+            <a:schemeClr val="accent1"/>
+          </a:fillRef>
+          <a:effectRef idx="2">
+            <a:schemeClr val="accent1"/>
+          </a:effectRef>
+          <a:fontRef idx="minor">
+            <a:schemeClr val="lt1"/>
+          </a:fontRef>
+        </p:style>
+        <p:txBody>
+          <a:bodyPr rtlCol="0" anchor="ctr"/>
+          <a:lstStyle/>
+          <a:p>
+            <a:pPr algn="ctr"/>
+          </a:p>
+        </p:txBody>
+      </p:sp>
+      <p:sp>
+        <p:nvSpPr>
+          <p:cNvPr id="13" name="TextBox 12"/>
+          <p:cNvSpPr txBox="1"/>
+          <p:nvPr/>
+        </p:nvSpPr>
+        <p:spPr>
+          <a:xfrm>
+            <a:off x="6629400" y="1691640"/>
+            <a:ext cx="3840480" cy="274320"/>
+          </a:xfrm>
+          <a:prstGeom prst="rect">
+            <a:avLst/>
+          </a:prstGeom>
+          <a:noFill/>
+        </p:spPr>
+        <p:txBody>
+          <a:bodyPr wrap="square" lIns="54864" rIns="54864" tIns="27432" bIns="27432">
+            <a:spAutoFit/>
+          </a:bodyPr>
+          <a:lstStyle/>
+          <a:p>
+            <a:pPr algn="l"/>
+            <a:r>
+              <a:rPr sz="1800" b="1">
+                <a:solidFill>
+                  <a:srgbClr val="52121E"/>
+                </a:solidFill>
+                <a:latin typeface="Arial"/>
+              </a:rPr>
+              <a:t>Neo4j: relationships as edges</a:t>
+            </a:r>
+          </a:p>
+        </p:txBody>
+      </p:sp>
+      <p:sp>
+        <p:nvSpPr>
+          <p:cNvPr id="14" name="TextBox 13"/>
+          <p:cNvSpPr txBox="1"/>
+          <p:nvPr/>
+        </p:nvSpPr>
+        <p:spPr>
+          <a:xfrm>
+            <a:off x="6629400" y="2148840"/>
+            <a:ext cx="4343400" cy="2286000"/>
+          </a:xfrm>
+          <a:prstGeom prst="rect">
+            <a:avLst/>
+          </a:prstGeom>
+          <a:noFill/>
+        </p:spPr>
+        <p:txBody>
+          <a:bodyPr wrap="square" lIns="54864" rIns="54864" tIns="27432" bIns="27432">
+            <a:spAutoFit/>
+          </a:bodyPr>
+          <a:lstStyle/>
+          <a:p>
+            <a:pPr algn="l">
+              <a:spcAft>
+                <a:spcPts val="500"/>
+              </a:spcAft>
+            </a:pPr>
+            <a:r>
+              <a:rPr sz="1700" b="0">
+                <a:solidFill>
+                  <a:srgbClr val="1A202C"/>
+                </a:solidFill>
+                <a:latin typeface="Arial"/>
+              </a:rPr>
+              <a:t>- Relationships are stored directly as graph edges</a:t>
+            </a:r>
+            <a:br/>
+            <a:r>
+              <a:rPr sz="1700" b="0">
+                <a:solidFill>
+                  <a:srgbClr val="1A202C"/>
+                </a:solidFill>
+                <a:latin typeface="Arial"/>
+              </a:rPr>
+              <a:t>- Cypher expresses paths with MATCH patterns</a:t>
+            </a:r>
+            <a:br/>
+            <a:r>
+              <a:rPr sz="1700" b="0">
+                <a:solidFill>
+                  <a:srgbClr val="1A202C"/>
+                </a:solidFill>
+                <a:latin typeface="Arial"/>
+              </a:rPr>
+              <a:t>- Good for citation paths and author networks</a:t>
+            </a:r>
+          </a:p>
+        </p:txBody>
+      </p:sp>
+      <p:sp>
+        <p:nvSpPr>
+          <p:cNvPr id="15" name="TextBox 14"/>
+          <p:cNvSpPr txBox="1"/>
+          <p:nvPr/>
+        </p:nvSpPr>
+        <p:spPr>
+          <a:xfrm>
+            <a:off x="6629400" y="4892040"/>
+            <a:ext cx="4343400" cy="502920"/>
+          </a:xfrm>
+          <a:prstGeom prst="rect">
+            <a:avLst/>
+          </a:prstGeom>
+          <a:noFill/>
+        </p:spPr>
+        <p:txBody>
+          <a:bodyPr wrap="square" lIns="54864" rIns="54864" tIns="27432" bIns="27432">
+            <a:spAutoFit/>
+          </a:bodyPr>
+          <a:lstStyle/>
+          <a:p>
+            <a:pPr algn="l"/>
+            <a:r>
+              <a:rPr sz="1500" b="0">
+                <a:solidFill>
+                  <a:srgbClr val="1A202C"/>
+                </a:solidFill>
+                <a:latin typeface="Arial"/>
+              </a:rPr>
+              <a:t>Course link: graph databases query by traversing paths instead of reconstructing paths through joins.</a:t>
+            </a:r>
+          </a:p>
+        </p:txBody>
+      </p:sp>
+    </p:spTree>
+  </p:cSld>
+  <p:clrMapOvr>
+    <a:masterClrMapping/>
+  </p:clrMapOvr>
+</p:sld>
+</file>
+
+<file path=ppt/slides/slide21.xml><?xml version="1.0" encoding="utf-8"?>
+<p:sld xmlns:a="http://schemas.openxmlformats.org/drawingml/2006/main" xmlns:p="http://schemas.openxmlformats.org/presentationml/2006/main" xmlns:r="http://schemas.openxmlformats.org/officeDocument/2006/relationships">
+  <p:cSld>
+    <p:spTree>
+      <p:nvGrpSpPr>
+        <p:cNvPr id="1" name=""/>
+        <p:cNvGrpSpPr/>
+        <p:nvPr/>
+      </p:nvGrpSpPr>
+      <p:grpSpPr/>
+      <p:sp>
+        <p:nvSpPr>
+          <p:cNvPr id="2" name="Rectangle 1"/>
+          <p:cNvSpPr/>
+          <p:nvPr/>
+        </p:nvSpPr>
+        <p:spPr>
+          <a:xfrm>
+            <a:off x="0" y="0"/>
+            <a:ext cx="12191695" cy="457200"/>
+          </a:xfrm>
+          <a:prstGeom prst="rect">
+            <a:avLst/>
+          </a:prstGeom>
+          <a:solidFill>
+            <a:srgbClr val="822332"/>
+          </a:solidFill>
+          <a:ln>
+            <a:noFill/>
+          </a:ln>
+        </p:spPr>
+        <p:style>
+          <a:lnRef idx="1">
+            <a:schemeClr val="accent1"/>
+          </a:lnRef>
+          <a:fillRef idx="3">
+            <a:schemeClr val="accent1"/>
+          </a:fillRef>
+          <a:effectRef idx="2">
+            <a:schemeClr val="accent1"/>
+          </a:effectRef>
+          <a:fontRef idx="minor">
+            <a:schemeClr val="lt1"/>
+          </a:fontRef>
+        </p:style>
+        <p:txBody>
+          <a:bodyPr rtlCol="0" anchor="ctr"/>
+          <a:lstStyle/>
+          <a:p>
+            <a:pPr algn="ctr"/>
+          </a:p>
+        </p:txBody>
+      </p:sp>
+      <p:sp>
+        <p:nvSpPr>
+          <p:cNvPr id="3" name="TextBox 2"/>
+          <p:cNvSpPr txBox="1"/>
+          <p:nvPr/>
+        </p:nvSpPr>
+        <p:spPr>
+          <a:xfrm>
+            <a:off x="502920" y="594360"/>
+            <a:ext cx="8961120" cy="411480"/>
+          </a:xfrm>
+          <a:prstGeom prst="rect">
+            <a:avLst/>
+          </a:prstGeom>
+          <a:noFill/>
+        </p:spPr>
+        <p:txBody>
+          <a:bodyPr wrap="square" lIns="54864" rIns="54864" tIns="27432" bIns="27432">
+            <a:spAutoFit/>
+          </a:bodyPr>
+          <a:lstStyle/>
+          <a:p>
+            <a:pPr algn="l"/>
+            <a:r>
+              <a:rPr sz="2700" b="1">
+                <a:solidFill>
+                  <a:srgbClr val="52121E"/>
+                </a:solidFill>
+                <a:latin typeface="Arial"/>
+              </a:rPr>
+              <a:t>Course Connection: Scope Choices</a:t>
+            </a:r>
+          </a:p>
+        </p:txBody>
+      </p:sp>
+      <p:sp>
+        <p:nvSpPr>
+          <p:cNvPr id="4" name="TextBox 3"/>
+          <p:cNvSpPr txBox="1"/>
+          <p:nvPr/>
+        </p:nvSpPr>
+        <p:spPr>
+          <a:xfrm>
+            <a:off x="530352" y="987552"/>
+            <a:ext cx="8686800" cy="256032"/>
+          </a:xfrm>
+          <a:prstGeom prst="rect">
+            <a:avLst/>
+          </a:prstGeom>
+          <a:noFill/>
+        </p:spPr>
+        <p:txBody>
+          <a:bodyPr wrap="square" lIns="54864" rIns="54864" tIns="27432" bIns="27432">
+            <a:spAutoFit/>
+          </a:bodyPr>
+          <a:lstStyle/>
+          <a:p>
+            <a:pPr algn="l"/>
+            <a:r>
+              <a:rPr sz="1200" b="0">
+                <a:solidFill>
+                  <a:srgbClr val="5C6876"/>
+                </a:solidFill>
+                <a:latin typeface="Arial"/>
+              </a:rPr>
+              <a:t>Why the project uses property graphs, not every course topic</a:t>
+            </a:r>
+          </a:p>
+        </p:txBody>
+      </p:sp>
+      <p:pic>
+        <p:nvPicPr>
+          <p:cNvPr id="5" name="Picture 4" descr="image.png"/>
+          <p:cNvPicPr>
+            <a:picLocks noChangeAspect="1"/>
+          </p:cNvPicPr>
+          <p:nvPr/>
+        </p:nvPicPr>
+        <p:blipFill>
+          <a:blip r:embed="rId2"/>
+          <a:stretch>
+            <a:fillRect/>
+          </a:stretch>
+        </p:blipFill>
+        <p:spPr>
+          <a:xfrm>
+            <a:off x="11018520" y="566928"/>
+            <a:ext cx="566928" cy="679252"/>
+          </a:xfrm>
+          <a:prstGeom prst="rect">
+            <a:avLst/>
+          </a:prstGeom>
+        </p:spPr>
+      </p:pic>
+      <p:sp>
+        <p:nvSpPr>
+          <p:cNvPr id="6" name="TextBox 5"/>
+          <p:cNvSpPr txBox="1"/>
+          <p:nvPr/>
+        </p:nvSpPr>
+        <p:spPr>
+          <a:xfrm>
+            <a:off x="502920" y="6446520"/>
+            <a:ext cx="4206240" cy="201168"/>
+          </a:xfrm>
+          <a:prstGeom prst="rect">
+            <a:avLst/>
+          </a:prstGeom>
+          <a:noFill/>
+        </p:spPr>
+        <p:txBody>
+          <a:bodyPr wrap="square" lIns="54864" rIns="54864" tIns="27432" bIns="27432">
+            <a:spAutoFit/>
+          </a:bodyPr>
+          <a:lstStyle/>
+          <a:p>
+            <a:pPr algn="l"/>
+            <a:r>
+              <a:rPr sz="800" b="0">
+                <a:solidFill>
+                  <a:srgbClr val="5C6876"/>
+                </a:solidFill>
+                <a:latin typeface="Arial"/>
+              </a:rPr>
+              <a:t>OpenAlex AI DBMS Comparison</a:t>
+            </a:r>
+          </a:p>
+        </p:txBody>
+      </p:sp>
+      <p:sp>
+        <p:nvSpPr>
+          <p:cNvPr id="7" name="TextBox 6"/>
+          <p:cNvSpPr txBox="1"/>
+          <p:nvPr/>
+        </p:nvSpPr>
+        <p:spPr>
+          <a:xfrm>
+            <a:off x="11292840" y="6446520"/>
+            <a:ext cx="411480" cy="201168"/>
+          </a:xfrm>
+          <a:prstGeom prst="rect">
+            <a:avLst/>
+          </a:prstGeom>
+          <a:noFill/>
+        </p:spPr>
+        <p:txBody>
+          <a:bodyPr wrap="square" lIns="54864" rIns="54864" tIns="27432" bIns="27432">
+            <a:spAutoFit/>
+          </a:bodyPr>
+          <a:lstStyle/>
+          <a:p>
+            <a:pPr algn="r"/>
+            <a:r>
+              <a:rPr sz="800" b="0">
+                <a:solidFill>
+                  <a:srgbClr val="5C6876"/>
+                </a:solidFill>
+                <a:latin typeface="Arial"/>
+              </a:rPr>
+              <a:t>21</a:t>
+            </a:r>
+          </a:p>
+        </p:txBody>
+      </p:sp>
+      <p:sp>
+        <p:nvSpPr>
+          <p:cNvPr id="8" name="Rounded Rectangle 7"/>
+          <p:cNvSpPr/>
+          <p:nvPr/>
+        </p:nvSpPr>
+        <p:spPr>
+          <a:xfrm>
+            <a:off x="685800" y="1417320"/>
+            <a:ext cx="3337560" cy="4434840"/>
+          </a:xfrm>
+          <a:prstGeom prst="roundRect">
+            <a:avLst/>
+          </a:prstGeom>
+          <a:solidFill>
+            <a:srgbClr val="FBFBFB"/>
+          </a:solidFill>
+          <a:ln w="15240">
+            <a:solidFill>
+              <a:srgbClr val="DCDCDC"/>
+            </a:solidFill>
+          </a:ln>
+        </p:spPr>
+        <p:style>
+          <a:lnRef idx="1">
+            <a:schemeClr val="accent1"/>
+          </a:lnRef>
+          <a:fillRef idx="3">
+            <a:schemeClr val="accent1"/>
+          </a:fillRef>
+          <a:effectRef idx="2">
+            <a:schemeClr val="accent1"/>
+          </a:effectRef>
+          <a:fontRef idx="minor">
+            <a:schemeClr val="lt1"/>
+          </a:fontRef>
+        </p:style>
+        <p:txBody>
+          <a:bodyPr rtlCol="0" anchor="ctr"/>
+          <a:lstStyle/>
+          <a:p>
+            <a:pPr algn="ctr"/>
+          </a:p>
+        </p:txBody>
+      </p:sp>
+      <p:sp>
+        <p:nvSpPr>
+          <p:cNvPr id="9" name="TextBox 8"/>
+          <p:cNvSpPr txBox="1"/>
+          <p:nvPr/>
+        </p:nvSpPr>
+        <p:spPr>
+          <a:xfrm>
+            <a:off x="960120" y="1691640"/>
+            <a:ext cx="2286000" cy="274320"/>
+          </a:xfrm>
+          <a:prstGeom prst="rect">
+            <a:avLst/>
+          </a:prstGeom>
+          <a:noFill/>
+        </p:spPr>
+        <p:txBody>
+          <a:bodyPr wrap="square" lIns="54864" rIns="54864" tIns="27432" bIns="27432">
+            <a:spAutoFit/>
+          </a:bodyPr>
+          <a:lstStyle/>
+          <a:p>
+            <a:pPr algn="l"/>
+            <a:r>
+              <a:rPr sz="1800" b="1">
+                <a:solidFill>
+                  <a:srgbClr val="52121E"/>
+                </a:solidFill>
+                <a:latin typeface="Arial"/>
+              </a:rPr>
+              <a:t>RDF databases</a:t>
+            </a:r>
+          </a:p>
+        </p:txBody>
+      </p:sp>
+      <p:sp>
+        <p:nvSpPr>
+          <p:cNvPr id="10" name="TextBox 9"/>
+          <p:cNvSpPr txBox="1"/>
+          <p:nvPr/>
+        </p:nvSpPr>
+        <p:spPr>
+          <a:xfrm>
+            <a:off x="960120" y="2148840"/>
+            <a:ext cx="2651760" cy="2514600"/>
+          </a:xfrm>
+          <a:prstGeom prst="rect">
+            <a:avLst/>
+          </a:prstGeom>
+          <a:noFill/>
+        </p:spPr>
+        <p:txBody>
+          <a:bodyPr wrap="square" lIns="54864" rIns="54864" tIns="27432" bIns="27432">
+            <a:spAutoFit/>
+          </a:bodyPr>
+          <a:lstStyle/>
+          <a:p>
+            <a:pPr algn="l">
+              <a:spcAft>
+                <a:spcPts val="500"/>
+              </a:spcAft>
+            </a:pPr>
+            <a:r>
+              <a:rPr sz="1600" b="0">
+                <a:solidFill>
+                  <a:srgbClr val="1A202C"/>
+                </a:solidFill>
+                <a:latin typeface="Arial"/>
+              </a:rPr>
+              <a:t>- RDF uses triples and semantic vocabularies</a:t>
+            </a:r>
+            <a:br/>
+            <a:r>
+              <a:rPr sz="1600" b="0">
+                <a:solidFill>
+                  <a:srgbClr val="1A202C"/>
+                </a:solidFill>
+                <a:latin typeface="Arial"/>
+              </a:rPr>
+              <a:t>- Useful for ontology-oriented data</a:t>
+            </a:r>
+            <a:br/>
+            <a:r>
+              <a:rPr sz="1600" b="0">
+                <a:solidFill>
+                  <a:srgbClr val="1A202C"/>
+                </a:solidFill>
+                <a:latin typeface="Arial"/>
+              </a:rPr>
+              <a:t>- We did not use RDF because the project compares PostgreSQL with Neo4j property graphs</a:t>
+            </a:r>
+          </a:p>
+        </p:txBody>
+      </p:sp>
+      <p:sp>
+        <p:nvSpPr>
+          <p:cNvPr id="11" name="Rounded Rectangle 10"/>
+          <p:cNvSpPr/>
+          <p:nvPr/>
+        </p:nvSpPr>
+        <p:spPr>
+          <a:xfrm>
+            <a:off x="4480560" y="1417320"/>
+            <a:ext cx="3337560" cy="4434840"/>
+          </a:xfrm>
+          <a:prstGeom prst="roundRect">
+            <a:avLst/>
+          </a:prstGeom>
+          <a:solidFill>
+            <a:srgbClr val="FBFBFB"/>
+          </a:solidFill>
+          <a:ln w="15240">
+            <a:solidFill>
+              <a:srgbClr val="DCDCDC"/>
+            </a:solidFill>
+          </a:ln>
+        </p:spPr>
+        <p:style>
+          <a:lnRef idx="1">
+            <a:schemeClr val="accent1"/>
+          </a:lnRef>
+          <a:fillRef idx="3">
+            <a:schemeClr val="accent1"/>
+          </a:fillRef>
+          <a:effectRef idx="2">
+            <a:schemeClr val="accent1"/>
+          </a:effectRef>
+          <a:fontRef idx="minor">
+            <a:schemeClr val="lt1"/>
+          </a:fontRef>
+        </p:style>
+        <p:txBody>
+          <a:bodyPr rtlCol="0" anchor="ctr"/>
+          <a:lstStyle/>
+          <a:p>
+            <a:pPr algn="ctr"/>
+          </a:p>
+        </p:txBody>
+      </p:sp>
+      <p:sp>
+        <p:nvSpPr>
+          <p:cNvPr id="12" name="TextBox 11"/>
+          <p:cNvSpPr txBox="1"/>
+          <p:nvPr/>
+        </p:nvSpPr>
+        <p:spPr>
+          <a:xfrm>
+            <a:off x="4754880" y="1691640"/>
+            <a:ext cx="2377440" cy="274320"/>
+          </a:xfrm>
+          <a:prstGeom prst="rect">
+            <a:avLst/>
+          </a:prstGeom>
+          <a:noFill/>
+        </p:spPr>
+        <p:txBody>
+          <a:bodyPr wrap="square" lIns="54864" rIns="54864" tIns="27432" bIns="27432">
+            <a:spAutoFit/>
+          </a:bodyPr>
+          <a:lstStyle/>
+          <a:p>
+            <a:pPr algn="l"/>
+            <a:r>
+              <a:rPr sz="1800" b="1">
+                <a:solidFill>
+                  <a:srgbClr val="52121E"/>
+                </a:solidFill>
+                <a:latin typeface="Arial"/>
+              </a:rPr>
+              <a:t>Data warehousing</a:t>
+            </a:r>
+          </a:p>
+        </p:txBody>
+      </p:sp>
+      <p:sp>
+        <p:nvSpPr>
+          <p:cNvPr id="13" name="TextBox 12"/>
+          <p:cNvSpPr txBox="1"/>
+          <p:nvPr/>
+        </p:nvSpPr>
+        <p:spPr>
+          <a:xfrm>
+            <a:off x="4754880" y="2148840"/>
+            <a:ext cx="2651760" cy="2514600"/>
+          </a:xfrm>
+          <a:prstGeom prst="rect">
+            <a:avLst/>
+          </a:prstGeom>
+          <a:noFill/>
+        </p:spPr>
+        <p:txBody>
+          <a:bodyPr wrap="square" lIns="54864" rIns="54864" tIns="27432" bIns="27432">
+            <a:spAutoFit/>
+          </a:bodyPr>
+          <a:lstStyle/>
+          <a:p>
+            <a:pPr algn="l">
+              <a:spcAft>
+                <a:spcPts val="500"/>
+              </a:spcAft>
+            </a:pPr>
+            <a:r>
+              <a:rPr sz="1600" b="0">
+                <a:solidFill>
+                  <a:srgbClr val="1A202C"/>
+                </a:solidFill>
+                <a:latin typeface="Arial"/>
+              </a:rPr>
+              <a:t>- DW focuses on fact tables, dimensions, star schemas, and OLAP</a:t>
+            </a:r>
+            <a:br/>
+            <a:r>
+              <a:rPr sz="1600" b="0">
+                <a:solidFill>
+                  <a:srgbClr val="1A202C"/>
+                </a:solidFill>
+                <a:latin typeface="Arial"/>
+              </a:rPr>
+              <a:t>- Our approved topic is DBMS comparison</a:t>
+            </a:r>
+            <a:br/>
+            <a:r>
+              <a:rPr sz="1600" b="0">
+                <a:solidFill>
+                  <a:srgbClr val="1A202C"/>
+                </a:solidFill>
+                <a:latin typeface="Arial"/>
+              </a:rPr>
+              <a:t>- So we do not present this as a warehouse project</a:t>
+            </a:r>
+          </a:p>
+        </p:txBody>
+      </p:sp>
+      <p:sp>
+        <p:nvSpPr>
+          <p:cNvPr id="14" name="Rounded Rectangle 13"/>
+          <p:cNvSpPr/>
+          <p:nvPr/>
+        </p:nvSpPr>
+        <p:spPr>
+          <a:xfrm>
+            <a:off x="8275320" y="1417320"/>
+            <a:ext cx="3337560" cy="4434840"/>
+          </a:xfrm>
+          <a:prstGeom prst="roundRect">
+            <a:avLst/>
+          </a:prstGeom>
+          <a:solidFill>
+            <a:srgbClr val="FBFBFB"/>
+          </a:solidFill>
+          <a:ln w="15240">
+            <a:solidFill>
+              <a:srgbClr val="DCDCDC"/>
+            </a:solidFill>
+          </a:ln>
+        </p:spPr>
+        <p:style>
+          <a:lnRef idx="1">
+            <a:schemeClr val="accent1"/>
+          </a:lnRef>
+          <a:fillRef idx="3">
+            <a:schemeClr val="accent1"/>
+          </a:fillRef>
+          <a:effectRef idx="2">
+            <a:schemeClr val="accent1"/>
+          </a:effectRef>
+          <a:fontRef idx="minor">
+            <a:schemeClr val="lt1"/>
+          </a:fontRef>
+        </p:style>
+        <p:txBody>
+          <a:bodyPr rtlCol="0" anchor="ctr"/>
+          <a:lstStyle/>
+          <a:p>
+            <a:pPr algn="ctr"/>
+          </a:p>
+        </p:txBody>
+      </p:sp>
+      <p:sp>
+        <p:nvSpPr>
+          <p:cNvPr id="15" name="TextBox 14"/>
+          <p:cNvSpPr txBox="1"/>
+          <p:nvPr/>
+        </p:nvSpPr>
+        <p:spPr>
+          <a:xfrm>
+            <a:off x="8549640" y="1691640"/>
+            <a:ext cx="2377440" cy="274320"/>
+          </a:xfrm>
+          <a:prstGeom prst="rect">
+            <a:avLst/>
+          </a:prstGeom>
+          <a:noFill/>
+        </p:spPr>
+        <p:txBody>
+          <a:bodyPr wrap="square" lIns="54864" rIns="54864" tIns="27432" bIns="27432">
+            <a:spAutoFit/>
+          </a:bodyPr>
+          <a:lstStyle/>
+          <a:p>
+            <a:pPr algn="l"/>
+            <a:r>
+              <a:rPr sz="1800" b="1">
+                <a:solidFill>
+                  <a:srgbClr val="52121E"/>
+                </a:solidFill>
+                <a:latin typeface="Arial"/>
+              </a:rPr>
+              <a:t>Query evaluation</a:t>
+            </a:r>
+          </a:p>
+        </p:txBody>
+      </p:sp>
+      <p:sp>
+        <p:nvSpPr>
+          <p:cNvPr id="16" name="TextBox 15"/>
+          <p:cNvSpPr txBox="1"/>
+          <p:nvPr/>
+        </p:nvSpPr>
+        <p:spPr>
+          <a:xfrm>
+            <a:off x="8549640" y="2148840"/>
+            <a:ext cx="2651760" cy="2514600"/>
+          </a:xfrm>
+          <a:prstGeom prst="rect">
+            <a:avLst/>
+          </a:prstGeom>
+          <a:noFill/>
+        </p:spPr>
+        <p:txBody>
+          <a:bodyPr wrap="square" lIns="54864" rIns="54864" tIns="27432" bIns="27432">
+            <a:spAutoFit/>
+          </a:bodyPr>
+          <a:lstStyle/>
+          <a:p>
+            <a:pPr algn="l">
+              <a:spcAft>
+                <a:spcPts val="500"/>
+              </a:spcAft>
+            </a:pPr>
+            <a:r>
+              <a:rPr sz="1600" b="0">
+                <a:solidFill>
+                  <a:srgbClr val="1A202C"/>
+                </a:solidFill>
+                <a:latin typeface="Arial"/>
+              </a:rPr>
+              <a:t>- Benchmarks connect to operator evaluation</a:t>
+            </a:r>
+            <a:br/>
+            <a:r>
+              <a:rPr sz="1600" b="0">
+                <a:solidFill>
+                  <a:srgbClr val="1A202C"/>
+                </a:solidFill>
+                <a:latin typeface="Arial"/>
+              </a:rPr>
+              <a:t>- PostgreSQL uses EXPLAIN ANALYZE</a:t>
+            </a:r>
+            <a:br/>
+            <a:r>
+              <a:rPr sz="1600" b="0">
+                <a:solidFill>
+                  <a:srgbClr val="1A202C"/>
+                </a:solidFill>
+                <a:latin typeface="Arial"/>
+              </a:rPr>
+              <a:t>- Neo4j uses PROFILE</a:t>
+            </a:r>
+            <a:br/>
+            <a:r>
+              <a:rPr sz="1600" b="0">
+                <a:solidFill>
+                  <a:srgbClr val="1A202C"/>
+                </a:solidFill>
+                <a:latin typeface="Arial"/>
+              </a:rPr>
+              <a:t>- Indexes and constraints influence access paths</a:t>
             </a:r>
           </a:p>
         </p:txBody>

</xml_diff>

<commit_message>
Add graph-focused benchmark analysis
</commit_message>
<xml_diff>
--- a/docs/OpenAlex_DBMS_Comparison_Sapienza.pptx
+++ b/docs/OpenAlex_DBMS_Comparison_Sapienza.pptx
@@ -26,6 +26,7 @@
     <p:sldId id="274" r:id="rId25"/>
     <p:sldId id="275" r:id="rId26"/>
     <p:sldId id="276" r:id="rId27"/>
+    <p:sldId id="277" r:id="rId28"/>
   </p:sldIdLst>
   <p:sldSz cx="12191695" cy="6858000" type="screen4x3"/>
   <p:notesSz cx="6858000" cy="9144000"/>
@@ -6894,43 +6895,80 @@
           <a:p>
             <a:pPr algn="l">
               <a:spcAft>
-                <a:spcPts val="600"/>
+                <a:spcPts val="200"/>
               </a:spcAft>
               <a:defRPr sz="1600"/>
             </a:pPr>
             <a:r>
-              <a:rPr sz="1600" b="0">
-                <a:solidFill>
-                  <a:srgbClr val="1A202C"/>
-                </a:solidFill>
-                <a:latin typeface="Arial"/>
+              <a:rPr sz="1400">
+                <a:solidFill>
+                  <a:srgbClr val="1F2430"/>
+                </a:solidFill>
+                <a:latin typeface="Aptos"/>
               </a:rPr>
               <a:t>- Author citation network</a:t>
             </a:r>
-            <a:br/>
-            <a:r>
-              <a:rPr sz="1600">
-                <a:solidFill>
-                  <a:srgbClr val="1A202C"/>
-                </a:solidFill>
-              </a:rPr>
-              <a:t>- Relationship traversal</a:t>
-            </a:r>
-            <a:br/>
-            <a:r>
-              <a:rPr sz="1600">
-                <a:solidFill>
-                  <a:srgbClr val="1A202C"/>
-                </a:solidFill>
+          </a:p>
+          <a:p>
+            <a:pPr>
+              <a:spcAft>
+                <a:spcPts val="200"/>
+              </a:spcAft>
+            </a:pPr>
+            <a:r>
+              <a:rPr sz="1400">
+                <a:solidFill>
+                  <a:srgbClr val="1F2430"/>
+                </a:solidFill>
+                <a:latin typeface="Aptos"/>
+              </a:rPr>
+              <a:t>- Two supplemental graph-heavy wins</a:t>
+            </a:r>
+          </a:p>
+          <a:p>
+            <a:pPr>
+              <a:spcAft>
+                <a:spcPts val="200"/>
+              </a:spcAft>
+            </a:pPr>
+            <a:r>
+              <a:rPr sz="1400">
+                <a:solidFill>
+                  <a:srgbClr val="1F2430"/>
+                </a:solidFill>
+                <a:latin typeface="Aptos"/>
+              </a:rPr>
+              <a:t>- Multi-hop traversal + topic overlap</a:t>
+            </a:r>
+          </a:p>
+          <a:p>
+            <a:pPr>
+              <a:spcAft>
+                <a:spcPts val="200"/>
+              </a:spcAft>
+            </a:pPr>
+            <a:r>
+              <a:rPr sz="1400">
+                <a:solidFill>
+                  <a:srgbClr val="1F2430"/>
+                </a:solidFill>
+                <a:latin typeface="Aptos"/>
               </a:rPr>
               <a:t>- Path-style graph questions</a:t>
             </a:r>
-            <a:br/>
-            <a:r>
-              <a:rPr sz="1600">
-                <a:solidFill>
-                  <a:srgbClr val="1A202C"/>
-                </a:solidFill>
+          </a:p>
+          <a:p>
+            <a:pPr>
+              <a:spcAft>
+                <a:spcPts val="200"/>
+              </a:spcAft>
+            </a:pPr>
+            <a:r>
+              <a:rPr sz="1400">
+                <a:solidFill>
+                  <a:srgbClr val="1F2430"/>
+                </a:solidFill>
+                <a:latin typeface="Aptos"/>
               </a:rPr>
               <a:t>- Visual exploration</a:t>
             </a:r>
@@ -8244,13 +8282,13 @@
           <a:p>
             <a:pPr algn="l"/>
             <a:r>
-              <a:rPr sz="2100" b="1">
+              <a:rPr sz="2000" b="1">
                 <a:solidFill>
                   <a:srgbClr val="1F2430"/>
                 </a:solidFill>
                 <a:latin typeface="Aptos"/>
               </a:rPr>
-              <a:t>PostgreSQL is the better fit for structured tabular analysis and most aggregations. Neo4j is more natural for citation paths and author networks.</a:t>
+              <a:t>PostgreSQL is the better fit for structured tabular analysis in the main workload. Neo4j becomes stronger when relationship traversal is central, especially citation networks and shared-topic citation paths.</a:t>
             </a:r>
           </a:p>
         </p:txBody>
@@ -10826,6 +10864,660 @@
                 <a:latin typeface="Arial"/>
               </a:rPr>
               <a:t>- Indexes and constraints influence access paths</a:t>
+            </a:r>
+          </a:p>
+        </p:txBody>
+      </p:sp>
+    </p:spTree>
+  </p:cSld>
+  <p:clrMapOvr>
+    <a:masterClrMapping/>
+  </p:clrMapOvr>
+</p:sld>
+</file>
+
+<file path=ppt/slides/slide22.xml><?xml version="1.0" encoding="utf-8"?>
+<p:sld xmlns:a="http://schemas.openxmlformats.org/drawingml/2006/main" xmlns:p="http://schemas.openxmlformats.org/presentationml/2006/main" xmlns:r="http://schemas.openxmlformats.org/officeDocument/2006/relationships">
+  <p:cSld>
+    <p:bg>
+      <p:bgPr>
+        <a:solidFill>
+          <a:srgbClr val="FFFFFF"/>
+        </a:solidFill>
+        <a:effectLst/>
+      </p:bgPr>
+    </p:bg>
+    <p:spTree>
+      <p:nvGrpSpPr>
+        <p:cNvPr id="1" name=""/>
+        <p:cNvGrpSpPr/>
+        <p:nvPr/>
+      </p:nvGrpSpPr>
+      <p:grpSpPr/>
+      <p:sp>
+        <p:nvSpPr>
+          <p:cNvPr id="2" name="Rectangle 1"/>
+          <p:cNvSpPr/>
+          <p:nvPr/>
+        </p:nvSpPr>
+        <p:spPr>
+          <a:xfrm>
+            <a:off x="0" y="0"/>
+            <a:ext cx="12191695" cy="310896"/>
+          </a:xfrm>
+          <a:prstGeom prst="rect">
+            <a:avLst/>
+          </a:prstGeom>
+          <a:solidFill>
+            <a:srgbClr val="822332"/>
+          </a:solidFill>
+          <a:ln>
+            <a:noFill/>
+          </a:ln>
+        </p:spPr>
+        <p:style>
+          <a:lnRef idx="1">
+            <a:schemeClr val="accent1"/>
+          </a:lnRef>
+          <a:fillRef idx="3">
+            <a:schemeClr val="accent1"/>
+          </a:fillRef>
+          <a:effectRef idx="2">
+            <a:schemeClr val="accent1"/>
+          </a:effectRef>
+          <a:fontRef idx="minor">
+            <a:schemeClr val="lt1"/>
+          </a:fontRef>
+        </p:style>
+        <p:txBody>
+          <a:bodyPr rtlCol="0" anchor="ctr"/>
+          <a:lstStyle/>
+          <a:p>
+            <a:pPr algn="ctr"/>
+          </a:p>
+        </p:txBody>
+      </p:sp>
+      <p:pic>
+        <p:nvPicPr>
+          <p:cNvPr id="3" name="Picture 2" descr="image.png"/>
+          <p:cNvPicPr>
+            <a:picLocks noChangeAspect="1"/>
+          </p:cNvPicPr>
+          <p:nvPr/>
+        </p:nvPicPr>
+        <p:blipFill>
+          <a:blip r:embed="rId2"/>
+          <a:stretch>
+            <a:fillRect/>
+          </a:stretch>
+        </p:blipFill>
+        <p:spPr>
+          <a:xfrm>
+            <a:off x="10287000" y="438912"/>
+            <a:ext cx="530352" cy="530352"/>
+          </a:xfrm>
+          <a:prstGeom prst="rect">
+            <a:avLst/>
+          </a:prstGeom>
+        </p:spPr>
+      </p:pic>
+      <p:sp>
+        <p:nvSpPr>
+          <p:cNvPr id="4" name="TextBox 3"/>
+          <p:cNvSpPr txBox="1"/>
+          <p:nvPr/>
+        </p:nvSpPr>
+        <p:spPr>
+          <a:xfrm>
+            <a:off x="502920" y="530352"/>
+            <a:ext cx="8961120" cy="384048"/>
+          </a:xfrm>
+          <a:prstGeom prst="rect">
+            <a:avLst/>
+          </a:prstGeom>
+          <a:noFill/>
+        </p:spPr>
+        <p:txBody>
+          <a:bodyPr wrap="none">
+            <a:spAutoFit/>
+          </a:bodyPr>
+          <a:lstStyle/>
+          <a:p>
+            <a:r>
+              <a:rPr sz="2500" b="1">
+                <a:solidFill>
+                  <a:srgbClr val="822332"/>
+                </a:solidFill>
+                <a:latin typeface="Aptos Display"/>
+              </a:rPr>
+              <a:t>Supplemental Benchmark: Graph-Focused Workload</a:t>
+            </a:r>
+          </a:p>
+        </p:txBody>
+      </p:sp>
+      <p:sp>
+        <p:nvSpPr>
+          <p:cNvPr id="5" name="TextBox 4"/>
+          <p:cNvSpPr txBox="1"/>
+          <p:nvPr/>
+        </p:nvSpPr>
+        <p:spPr>
+          <a:xfrm>
+            <a:off x="512064" y="932688"/>
+            <a:ext cx="8686800" cy="256032"/>
+          </a:xfrm>
+          <a:prstGeom prst="rect">
+            <a:avLst/>
+          </a:prstGeom>
+          <a:noFill/>
+        </p:spPr>
+        <p:txBody>
+          <a:bodyPr wrap="none">
+            <a:spAutoFit/>
+          </a:bodyPr>
+          <a:lstStyle/>
+          <a:p>
+            <a:r>
+              <a:rPr sz="1000">
+                <a:solidFill>
+                  <a:srgbClr val="566373"/>
+                </a:solidFill>
+                <a:latin typeface="Aptos"/>
+              </a:rPr>
+              <a:t>Extra query pairs added to test whether Neo4j improves on more graph-shaped questions</a:t>
+            </a:r>
+          </a:p>
+        </p:txBody>
+      </p:sp>
+      <p:sp>
+        <p:nvSpPr>
+          <p:cNvPr id="6" name="Rounded Rectangle 5"/>
+          <p:cNvSpPr/>
+          <p:nvPr/>
+        </p:nvSpPr>
+        <p:spPr>
+          <a:xfrm>
+            <a:off x="658368" y="1481328"/>
+            <a:ext cx="2880360" cy="3977639"/>
+          </a:xfrm>
+          <a:prstGeom prst="roundRect">
+            <a:avLst/>
+          </a:prstGeom>
+          <a:solidFill>
+            <a:srgbClr val="FFFFFF"/>
+          </a:solidFill>
+          <a:ln w="12700">
+            <a:solidFill>
+              <a:srgbClr val="E0D2D6"/>
+            </a:solidFill>
+          </a:ln>
+        </p:spPr>
+        <p:style>
+          <a:lnRef idx="1">
+            <a:schemeClr val="accent1"/>
+          </a:lnRef>
+          <a:fillRef idx="3">
+            <a:schemeClr val="accent1"/>
+          </a:fillRef>
+          <a:effectRef idx="2">
+            <a:schemeClr val="accent1"/>
+          </a:effectRef>
+          <a:fontRef idx="minor">
+            <a:schemeClr val="lt1"/>
+          </a:fontRef>
+        </p:style>
+        <p:txBody>
+          <a:bodyPr rtlCol="0" anchor="ctr"/>
+          <a:lstStyle/>
+          <a:p>
+            <a:pPr algn="ctr"/>
+          </a:p>
+        </p:txBody>
+      </p:sp>
+      <p:sp>
+        <p:nvSpPr>
+          <p:cNvPr id="7" name="TextBox 6"/>
+          <p:cNvSpPr txBox="1"/>
+          <p:nvPr/>
+        </p:nvSpPr>
+        <p:spPr>
+          <a:xfrm>
+            <a:off x="859536" y="1682496"/>
+            <a:ext cx="2478024" cy="3657599"/>
+          </a:xfrm>
+          <a:prstGeom prst="rect">
+            <a:avLst/>
+          </a:prstGeom>
+          <a:noFill/>
+        </p:spPr>
+        <p:txBody>
+          <a:bodyPr wrap="square">
+            <a:spAutoFit/>
+          </a:bodyPr>
+          <a:lstStyle/>
+          <a:p>
+            <a:r>
+              <a:rPr sz="1400" b="1">
+                <a:solidFill>
+                  <a:srgbClr val="822332"/>
+                </a:solidFill>
+                <a:latin typeface="Aptos"/>
+              </a:rPr>
+              <a:t>What changed</a:t>
+            </a:r>
+          </a:p>
+          <a:p>
+            <a:pPr>
+              <a:spcBef>
+                <a:spcPts val="500"/>
+              </a:spcBef>
+            </a:pPr>
+            <a:r>
+              <a:rPr sz="1100">
+                <a:solidFill>
+                  <a:srgbClr val="1F2430"/>
+                </a:solidFill>
+                <a:latin typeface="Aptos"/>
+              </a:rPr>
+              <a:t>- Original 11-query benchmark kept unchanged</a:t>
+            </a:r>
+          </a:p>
+          <a:p>
+            <a:pPr>
+              <a:spcBef>
+                <a:spcPts val="500"/>
+              </a:spcBef>
+            </a:pPr>
+            <a:r>
+              <a:rPr sz="1100">
+                <a:solidFill>
+                  <a:srgbClr val="1F2430"/>
+                </a:solidFill>
+                <a:latin typeface="Aptos"/>
+              </a:rPr>
+              <a:t>- Added 7 supplemental graph-focused query pairs</a:t>
+            </a:r>
+          </a:p>
+          <a:p>
+            <a:pPr>
+              <a:spcBef>
+                <a:spcPts val="500"/>
+              </a:spcBef>
+            </a:pPr>
+            <a:r>
+              <a:rPr sz="1100">
+                <a:solidFill>
+                  <a:srgbClr val="1F2430"/>
+                </a:solidFill>
+                <a:latin typeface="Aptos"/>
+              </a:rPr>
+              <a:t>- Workload includes neighborhoods, two-hop citation paths, and topic-overlap citation networks</a:t>
+            </a:r>
+          </a:p>
+        </p:txBody>
+      </p:sp>
+      <p:sp>
+        <p:nvSpPr>
+          <p:cNvPr id="8" name="Rounded Rectangle 7"/>
+          <p:cNvSpPr/>
+          <p:nvPr/>
+        </p:nvSpPr>
+        <p:spPr>
+          <a:xfrm>
+            <a:off x="3794760" y="1481328"/>
+            <a:ext cx="3063240" cy="3977639"/>
+          </a:xfrm>
+          <a:prstGeom prst="roundRect">
+            <a:avLst/>
+          </a:prstGeom>
+          <a:solidFill>
+            <a:srgbClr val="FFFFFF"/>
+          </a:solidFill>
+          <a:ln w="12700">
+            <a:solidFill>
+              <a:srgbClr val="E0D2D6"/>
+            </a:solidFill>
+          </a:ln>
+        </p:spPr>
+        <p:style>
+          <a:lnRef idx="1">
+            <a:schemeClr val="accent1"/>
+          </a:lnRef>
+          <a:fillRef idx="3">
+            <a:schemeClr val="accent1"/>
+          </a:fillRef>
+          <a:effectRef idx="2">
+            <a:schemeClr val="accent1"/>
+          </a:effectRef>
+          <a:fontRef idx="minor">
+            <a:schemeClr val="lt1"/>
+          </a:fontRef>
+        </p:style>
+        <p:txBody>
+          <a:bodyPr rtlCol="0" anchor="ctr"/>
+          <a:lstStyle/>
+          <a:p>
+            <a:pPr algn="ctr"/>
+          </a:p>
+        </p:txBody>
+      </p:sp>
+      <p:sp>
+        <p:nvSpPr>
+          <p:cNvPr id="9" name="TextBox 8"/>
+          <p:cNvSpPr txBox="1"/>
+          <p:nvPr/>
+        </p:nvSpPr>
+        <p:spPr>
+          <a:xfrm>
+            <a:off x="3995928" y="1682496"/>
+            <a:ext cx="2660904" cy="3657599"/>
+          </a:xfrm>
+          <a:prstGeom prst="rect">
+            <a:avLst/>
+          </a:prstGeom>
+          <a:noFill/>
+        </p:spPr>
+        <p:txBody>
+          <a:bodyPr wrap="square">
+            <a:spAutoFit/>
+          </a:bodyPr>
+          <a:lstStyle/>
+          <a:p>
+            <a:r>
+              <a:rPr sz="1400" b="1">
+                <a:solidFill>
+                  <a:srgbClr val="822332"/>
+                </a:solidFill>
+                <a:latin typeface="Aptos"/>
+              </a:rPr>
+              <a:t>Measured result</a:t>
+            </a:r>
+          </a:p>
+          <a:p>
+            <a:pPr>
+              <a:spcBef>
+                <a:spcPts val="500"/>
+              </a:spcBef>
+            </a:pPr>
+            <a:r>
+              <a:rPr sz="1100">
+                <a:solidFill>
+                  <a:srgbClr val="1F2430"/>
+                </a:solidFill>
+                <a:latin typeface="Aptos"/>
+              </a:rPr>
+              <a:t>- PostgreSQL still wins small anchored lookups</a:t>
+            </a:r>
+          </a:p>
+          <a:p>
+            <a:pPr>
+              <a:spcBef>
+                <a:spcPts val="500"/>
+              </a:spcBef>
+            </a:pPr>
+            <a:r>
+              <a:rPr sz="1100">
+                <a:solidFill>
+                  <a:srgbClr val="1F2430"/>
+                </a:solidFill>
+                <a:latin typeface="Aptos"/>
+              </a:rPr>
+              <a:t>- Neo4j wins two-hop author citation network: 39.2 ms vs 43.0 ms</a:t>
+            </a:r>
+          </a:p>
+          <a:p>
+            <a:pPr>
+              <a:spcBef>
+                <a:spcPts val="500"/>
+              </a:spcBef>
+            </a:pPr>
+            <a:r>
+              <a:rPr sz="1100">
+                <a:solidFill>
+                  <a:srgbClr val="1F2430"/>
+                </a:solidFill>
+                <a:latin typeface="Aptos"/>
+              </a:rPr>
+              <a:t>- Neo4j wins author citation + shared topic: 338.0 ms vs 783.0 ms</a:t>
+            </a:r>
+          </a:p>
+        </p:txBody>
+      </p:sp>
+      <p:sp>
+        <p:nvSpPr>
+          <p:cNvPr id="10" name="Rounded Rectangle 9"/>
+          <p:cNvSpPr/>
+          <p:nvPr/>
+        </p:nvSpPr>
+        <p:spPr>
+          <a:xfrm>
+            <a:off x="7114032" y="1481328"/>
+            <a:ext cx="3337560" cy="3977639"/>
+          </a:xfrm>
+          <a:prstGeom prst="roundRect">
+            <a:avLst/>
+          </a:prstGeom>
+          <a:solidFill>
+            <a:srgbClr val="FFFFFF"/>
+          </a:solidFill>
+          <a:ln w="12700">
+            <a:solidFill>
+              <a:srgbClr val="E0D2D6"/>
+            </a:solidFill>
+          </a:ln>
+        </p:spPr>
+        <p:style>
+          <a:lnRef idx="1">
+            <a:schemeClr val="accent1"/>
+          </a:lnRef>
+          <a:fillRef idx="3">
+            <a:schemeClr val="accent1"/>
+          </a:fillRef>
+          <a:effectRef idx="2">
+            <a:schemeClr val="accent1"/>
+          </a:effectRef>
+          <a:fontRef idx="minor">
+            <a:schemeClr val="lt1"/>
+          </a:fontRef>
+        </p:style>
+        <p:txBody>
+          <a:bodyPr rtlCol="0" anchor="ctr"/>
+          <a:lstStyle/>
+          <a:p>
+            <a:pPr algn="ctr"/>
+          </a:p>
+        </p:txBody>
+      </p:sp>
+      <p:sp>
+        <p:nvSpPr>
+          <p:cNvPr id="11" name="TextBox 10"/>
+          <p:cNvSpPr txBox="1"/>
+          <p:nvPr/>
+        </p:nvSpPr>
+        <p:spPr>
+          <a:xfrm>
+            <a:off x="7315200" y="1682496"/>
+            <a:ext cx="2935224" cy="3657599"/>
+          </a:xfrm>
+          <a:prstGeom prst="rect">
+            <a:avLst/>
+          </a:prstGeom>
+          <a:noFill/>
+        </p:spPr>
+        <p:txBody>
+          <a:bodyPr wrap="square">
+            <a:spAutoFit/>
+          </a:bodyPr>
+          <a:lstStyle/>
+          <a:p>
+            <a:r>
+              <a:rPr sz="1400" b="1">
+                <a:solidFill>
+                  <a:srgbClr val="822332"/>
+                </a:solidFill>
+                <a:latin typeface="Aptos"/>
+              </a:rPr>
+              <a:t>Interpretation</a:t>
+            </a:r>
+          </a:p>
+          <a:p>
+            <a:pPr>
+              <a:spcBef>
+                <a:spcPts val="500"/>
+              </a:spcBef>
+            </a:pPr>
+            <a:r>
+              <a:rPr sz="1100">
+                <a:solidFill>
+                  <a:srgbClr val="1F2430"/>
+                </a:solidFill>
+                <a:latin typeface="Aptos"/>
+              </a:rPr>
+              <a:t>- Neo4j is not automatically faster for every graph-looking query</a:t>
+            </a:r>
+          </a:p>
+          <a:p>
+            <a:pPr>
+              <a:spcBef>
+                <a:spcPts val="500"/>
+              </a:spcBef>
+            </a:pPr>
+            <a:r>
+              <a:rPr sz="1100">
+                <a:solidFill>
+                  <a:srgbClr val="1F2430"/>
+                </a:solidFill>
+                <a:latin typeface="Aptos"/>
+              </a:rPr>
+              <a:t>- Advantage appears when traversal combines several relationship types</a:t>
+            </a:r>
+          </a:p>
+          <a:p>
+            <a:pPr>
+              <a:spcBef>
+                <a:spcPts val="500"/>
+              </a:spcBef>
+            </a:pPr>
+            <a:r>
+              <a:rPr sz="1100">
+                <a:solidFill>
+                  <a:srgbClr val="1F2430"/>
+                </a:solidFill>
+                <a:latin typeface="Aptos"/>
+              </a:rPr>
+              <a:t>- This supports the balanced model-choice conclusion</a:t>
+            </a:r>
+          </a:p>
+        </p:txBody>
+      </p:sp>
+      <p:sp>
+        <p:nvSpPr>
+          <p:cNvPr id="12" name="Rectangle 11"/>
+          <p:cNvSpPr/>
+          <p:nvPr/>
+        </p:nvSpPr>
+        <p:spPr>
+          <a:xfrm>
+            <a:off x="457200" y="6309360"/>
+            <a:ext cx="10058400" cy="12700"/>
+          </a:xfrm>
+          <a:prstGeom prst="rect">
+            <a:avLst/>
+          </a:prstGeom>
+          <a:solidFill>
+            <a:srgbClr val="E6E6E6"/>
+          </a:solidFill>
+          <a:ln>
+            <a:noFill/>
+          </a:ln>
+        </p:spPr>
+        <p:style>
+          <a:lnRef idx="1">
+            <a:schemeClr val="accent1"/>
+          </a:lnRef>
+          <a:fillRef idx="3">
+            <a:schemeClr val="accent1"/>
+          </a:fillRef>
+          <a:effectRef idx="2">
+            <a:schemeClr val="accent1"/>
+          </a:effectRef>
+          <a:fontRef idx="minor">
+            <a:schemeClr val="lt1"/>
+          </a:fontRef>
+        </p:style>
+        <p:txBody>
+          <a:bodyPr rtlCol="0" anchor="ctr"/>
+          <a:lstStyle/>
+          <a:p>
+            <a:pPr algn="ctr"/>
+          </a:p>
+        </p:txBody>
+      </p:sp>
+      <p:sp>
+        <p:nvSpPr>
+          <p:cNvPr id="13" name="TextBox 12"/>
+          <p:cNvSpPr txBox="1"/>
+          <p:nvPr/>
+        </p:nvSpPr>
+        <p:spPr>
+          <a:xfrm>
+            <a:off x="502920" y="6419088"/>
+            <a:ext cx="4114800" cy="182880"/>
+          </a:xfrm>
+          <a:prstGeom prst="rect">
+            <a:avLst/>
+          </a:prstGeom>
+          <a:noFill/>
+        </p:spPr>
+        <p:txBody>
+          <a:bodyPr wrap="none">
+            <a:spAutoFit/>
+          </a:bodyPr>
+          <a:lstStyle/>
+          <a:p>
+            <a:r>
+              <a:rPr sz="600">
+                <a:solidFill>
+                  <a:srgbClr val="566373"/>
+                </a:solidFill>
+                <a:latin typeface="Aptos"/>
+              </a:rPr>
+              <a:t>OpenAlex AI DBMS Comparison</a:t>
+            </a:r>
+          </a:p>
+        </p:txBody>
+      </p:sp>
+      <p:sp>
+        <p:nvSpPr>
+          <p:cNvPr id="14" name="TextBox 13"/>
+          <p:cNvSpPr txBox="1"/>
+          <p:nvPr/>
+        </p:nvSpPr>
+        <p:spPr>
+          <a:xfrm>
+            <a:off x="10378440" y="6400800"/>
+            <a:ext cx="228600" cy="182880"/>
+          </a:xfrm>
+          <a:prstGeom prst="rect">
+            <a:avLst/>
+          </a:prstGeom>
+          <a:noFill/>
+        </p:spPr>
+        <p:txBody>
+          <a:bodyPr wrap="none">
+            <a:spAutoFit/>
+          </a:bodyPr>
+          <a:lstStyle/>
+          <a:p>
+            <a:pPr algn="r"/>
+            <a:r>
+              <a:rPr sz="700">
+                <a:solidFill>
+                  <a:srgbClr val="566373"/>
+                </a:solidFill>
+                <a:latin typeface="Aptos"/>
+              </a:rPr>
+              <a:t>22</a:t>
             </a:r>
           </a:p>
         </p:txBody>

</xml_diff>